<commit_message>
Refactor: Transition completely from Zentra to Grimoire, update presentation with prototype, and add root .gitignore and README
</commit_message>
<xml_diff>
--- a/BotS_GRIMOIRE.pptx
+++ b/BotS_GRIMOIRE.pptx
@@ -6637,7 +6637,7 @@
         <p:spPr>
           <a:xfrm>
             <a:off x="800000" y="5000000"/>
-            <a:ext cx="8400000" cy="660000"/>
+            <a:ext cx="8400000" cy="650000"/>
           </a:xfrm>
           <a:prstGeom prst="roundRect">
             <a:avLst>
@@ -6693,8 +6693,8 @@
         </p:nvSpPr>
         <p:spPr>
           <a:xfrm>
-            <a:off x="800000" y="5885000"/>
-            <a:ext cx="8400000" cy="660000"/>
+            <a:off x="800000" y="5860000"/>
+            <a:ext cx="8400000" cy="650000"/>
           </a:xfrm>
           <a:prstGeom prst="roundRect">
             <a:avLst>
@@ -6750,8 +6750,8 @@
         </p:nvSpPr>
         <p:spPr>
           <a:xfrm>
-            <a:off x="800000" y="6770000"/>
-            <a:ext cx="8400000" cy="660000"/>
+            <a:off x="800000" y="6720000"/>
+            <a:ext cx="8400000" cy="650000"/>
           </a:xfrm>
           <a:prstGeom prst="roundRect">
             <a:avLst>
@@ -6807,8 +6807,8 @@
         </p:nvSpPr>
         <p:spPr>
           <a:xfrm>
-            <a:off x="800000" y="7655000"/>
-            <a:ext cx="8400000" cy="660000"/>
+            <a:off x="800000" y="7580000"/>
+            <a:ext cx="8400000" cy="650000"/>
           </a:xfrm>
           <a:prstGeom prst="roundRect">
             <a:avLst>
@@ -6864,8 +6864,8 @@
         </p:nvSpPr>
         <p:spPr>
           <a:xfrm>
-            <a:off x="800000" y="8540000"/>
-            <a:ext cx="8400000" cy="660000"/>
+            <a:off x="800000" y="8440000"/>
+            <a:ext cx="8400000" cy="650000"/>
           </a:xfrm>
           <a:prstGeom prst="roundRect">
             <a:avLst>
@@ -6921,8 +6921,8 @@
         </p:nvSpPr>
         <p:spPr>
           <a:xfrm>
-            <a:off x="9800000" y="4450000"/>
-            <a:ext cx="7600000" cy="450000"/>
+            <a:off x="9700000" y="4450000"/>
+            <a:ext cx="7800000" cy="450000"/>
           </a:xfrm>
           <a:prstGeom prst="rect">
             <a:avLst/>
@@ -6949,22 +6949,22 @@
       </p:sp>
       <p:pic>
         <p:nvPicPr>
-          <p:cNvPr id="535" name="Picture 534" descr="interview_prototype_showcase.png"/>
+          <p:cNvPr id="540" name="Picture 539" descr="gautam_variant_framed.png"/>
           <p:cNvPicPr>
             <a:picLocks noChangeAspect="1"/>
           </p:cNvPicPr>
           <p:nvPr/>
         </p:nvPicPr>
         <p:blipFill>
-          <a:blip r:embed="rId7"/>
+          <a:blip r:embed="rId8"/>
           <a:stretch>
             <a:fillRect/>
           </a:stretch>
         </p:blipFill>
         <p:spPr>
           <a:xfrm>
-            <a:off x="9800000" y="5000000"/>
-            <a:ext cx="7600000" cy="4209360"/>
+            <a:off x="9700000" y="5000000"/>
+            <a:ext cx="7800000" cy="4069282"/>
           </a:xfrm>
           <a:prstGeom prst="rect">
             <a:avLst/>
@@ -6973,14 +6973,14 @@
       </p:pic>
       <p:sp>
         <p:nvSpPr>
-          <p:cNvPr id="536" name="Down Arrow 535"/>
+          <p:cNvPr id="541" name="Down Arrow 540"/>
           <p:cNvSpPr/>
           <p:nvPr/>
         </p:nvSpPr>
         <p:spPr>
           <a:xfrm>
-            <a:off x="4880000" y="5685000"/>
-            <a:ext cx="240000" cy="175000"/>
+            <a:off x="4880000" y="5672500"/>
+            <a:ext cx="240000" cy="165000"/>
           </a:xfrm>
           <a:prstGeom prst="downArrow">
             <a:avLst/>
@@ -7016,14 +7016,14 @@
       </p:sp>
       <p:sp>
         <p:nvSpPr>
-          <p:cNvPr id="537" name="Down Arrow 536"/>
+          <p:cNvPr id="542" name="Down Arrow 541"/>
           <p:cNvSpPr/>
           <p:nvPr/>
         </p:nvSpPr>
         <p:spPr>
           <a:xfrm>
-            <a:off x="4880000" y="6570000"/>
-            <a:ext cx="240000" cy="175000"/>
+            <a:off x="4880000" y="6532500"/>
+            <a:ext cx="240000" cy="165000"/>
           </a:xfrm>
           <a:prstGeom prst="downArrow">
             <a:avLst/>
@@ -7059,14 +7059,14 @@
       </p:sp>
       <p:sp>
         <p:nvSpPr>
-          <p:cNvPr id="538" name="Down Arrow 537"/>
+          <p:cNvPr id="543" name="Down Arrow 542"/>
           <p:cNvSpPr/>
           <p:nvPr/>
         </p:nvSpPr>
         <p:spPr>
           <a:xfrm>
-            <a:off x="4880000" y="7455000"/>
-            <a:ext cx="240000" cy="175000"/>
+            <a:off x="4880000" y="7392500"/>
+            <a:ext cx="240000" cy="165000"/>
           </a:xfrm>
           <a:prstGeom prst="downArrow">
             <a:avLst/>
@@ -7102,14 +7102,14 @@
       </p:sp>
       <p:sp>
         <p:nvSpPr>
-          <p:cNvPr id="539" name="Down Arrow 538"/>
+          <p:cNvPr id="544" name="Down Arrow 543"/>
           <p:cNvSpPr/>
           <p:nvPr/>
         </p:nvSpPr>
         <p:spPr>
           <a:xfrm>
-            <a:off x="4880000" y="8340000"/>
-            <a:ext cx="240000" cy="175000"/>
+            <a:off x="4880000" y="8252500"/>
+            <a:ext cx="240000" cy="165000"/>
           </a:xfrm>
           <a:prstGeom prst="downArrow">
             <a:avLst/>

</xml_diff>